<commit_message>
fix: update presentation text to Spanish for final project report
</commit_message>
<xml_diff>
--- a/docs/VinylEth_Presentation.pptx
+++ b/docs/VinylEth_Presentation.pptx
@@ -3258,7 +3258,7 @@
                 </a:solidFill>
                 <a:latin typeface="Calibri"/>
               </a:rPr>
-              <a:t>Final Project Report</a:t>
+              <a:t>Informe Final del Proyecto</a:t>
             </a:r>
           </a:p>
         </p:txBody>
@@ -3293,7 +3293,7 @@
                 </a:solidFill>
                 <a:latin typeface="Calibri"/>
               </a:rPr>
-              <a:t>Intermodular Project UD3  ·  CIFP Francesc de Borja Moll</a:t>
+              <a:t>Projecte Intermodular UD3  ·  CIFP Francesc de Borja Moll</a:t>
             </a:r>
           </a:p>
         </p:txBody>
@@ -3363,7 +3363,7 @@
                 </a:solidFill>
                 <a:latin typeface="Calibri"/>
               </a:rPr>
-              <a:t>June 2026  ·  github.com/Castor909/projecte-intermodular</a:t>
+              <a:t>Junio 2026  ·  github.com/Castor909/projecte-intermodular</a:t>
             </a:r>
           </a:p>
         </p:txBody>
@@ -3640,7 +3640,7 @@
                 </a:solidFill>
                 <a:latin typeface="Calibri"/>
               </a:rPr>
-              <a:t>Payments</a:t>
+              <a:t>Pagos</a:t>
             </a:r>
           </a:p>
         </p:txBody>
@@ -3796,7 +3796,7 @@
                 </a:solidFill>
                 <a:latin typeface="Calibri"/>
               </a:rPr>
-              <a:t>Network</a:t>
+              <a:t>Red</a:t>
             </a:r>
           </a:p>
         </p:txBody>
@@ -4091,7 +4091,7 @@
                 </a:solidFill>
                 <a:latin typeface="Calibri"/>
               </a:rPr>
-              <a:t>Project Evolution</a:t>
+              <a:t>Evolucion del Proyecto</a:t>
             </a:r>
           </a:p>
         </p:txBody>
@@ -4247,7 +4247,7 @@
                 </a:solidFill>
                 <a:latin typeface="Calibri"/>
               </a:rPr>
-              <a:t>Initial Setup</a:t>
+              <a:t>Configuracion Inicial</a:t>
             </a:r>
           </a:p>
         </p:txBody>
@@ -4329,7 +4329,7 @@
                 </a:solidFill>
                 <a:latin typeface="Calibri"/>
               </a:rPr>
-              <a:t>· React + mock catalog</a:t>
+              <a:t>· React + catalogo simulado</a:t>
             </a:r>
           </a:p>
           <a:p>
@@ -4345,7 +4345,7 @@
                 </a:solidFill>
                 <a:latin typeface="Calibri"/>
               </a:rPr>
-              <a:t>· Express skeleton</a:t>
+              <a:t>· Esqueleto de Express</a:t>
             </a:r>
           </a:p>
           <a:p>
@@ -4361,7 +4361,7 @@
                 </a:solidFill>
                 <a:latin typeface="Calibri"/>
               </a:rPr>
-              <a:t>· Design system defined</a:t>
+              <a:t>· Sistema de diseno definido</a:t>
             </a:r>
           </a:p>
         </p:txBody>
@@ -4509,7 +4509,7 @@
                 </a:solidFill>
                 <a:latin typeface="Calibri"/>
               </a:rPr>
-              <a:t>Backend + Cart</a:t>
+              <a:t>Backend + Carrito</a:t>
             </a:r>
           </a:p>
         </p:txBody>
@@ -4591,7 +4591,7 @@
                 </a:solidFill>
                 <a:latin typeface="Calibri"/>
               </a:rPr>
-              <a:t>· MongoDB + Album model</a:t>
+              <a:t>· MongoDB + modelo Album</a:t>
             </a:r>
           </a:p>
           <a:p>
@@ -4607,7 +4607,7 @@
                 </a:solidFill>
                 <a:latin typeface="Calibri"/>
               </a:rPr>
-              <a:t>· REST API (albums list &amp; detail)</a:t>
+              <a:t>· API REST (lista y detalle)</a:t>
             </a:r>
           </a:p>
           <a:p>
@@ -4623,7 +4623,7 @@
                 </a:solidFill>
                 <a:latin typeface="Calibri"/>
               </a:rPr>
-              <a:t>· Cart with localStorage</a:t>
+              <a:t>· Carrito con localStorage</a:t>
             </a:r>
           </a:p>
         </p:txBody>
@@ -4771,7 +4771,7 @@
                 </a:solidFill>
                 <a:latin typeface="Calibri"/>
               </a:rPr>
-              <a:t>Wallet + Search</a:t>
+              <a:t>Wallet + Busqueda</a:t>
             </a:r>
           </a:p>
         </p:txBody>
@@ -4853,7 +4853,7 @@
                 </a:solidFill>
                 <a:latin typeface="Calibri"/>
               </a:rPr>
-              <a:t>· MetaMask connect in header</a:t>
+              <a:t>· Conexion MetaMask en header</a:t>
             </a:r>
           </a:p>
           <a:p>
@@ -4869,7 +4869,7 @@
                 </a:solidFill>
                 <a:latin typeface="Calibri"/>
               </a:rPr>
-              <a:t>· Cart quantity controls</a:t>
+              <a:t>· Controles de cantidad en carrito</a:t>
             </a:r>
           </a:p>
           <a:p>
@@ -4885,7 +4885,7 @@
                 </a:solidFill>
                 <a:latin typeface="Calibri"/>
               </a:rPr>
-              <a:t>· Catalog search, filter, sort</a:t>
+              <a:t>· Busqueda, filtro y orden en catalogo</a:t>
             </a:r>
           </a:p>
         </p:txBody>
@@ -5033,7 +5033,7 @@
                 </a:solidFill>
                 <a:latin typeface="Calibri"/>
               </a:rPr>
-              <a:t>Complete App</a:t>
+              <a:t>App Completa</a:t>
             </a:r>
           </a:p>
         </p:txBody>
@@ -5115,7 +5115,7 @@
                 </a:solidFill>
                 <a:latin typeface="Calibri"/>
               </a:rPr>
-              <a:t>· Full payment flow + orders</a:t>
+              <a:t>· Flujo de pago completo + pedidos</a:t>
             </a:r>
           </a:p>
           <a:p>
@@ -5131,7 +5131,7 @@
                 </a:solidFill>
                 <a:latin typeface="Calibri"/>
               </a:rPr>
-              <a:t>· JWT auth + admin panel</a:t>
+              <a:t>· Auth JWT + panel de admin</a:t>
             </a:r>
           </a:p>
           <a:p>
@@ -5147,7 +5147,7 @@
                 </a:solidFill>
                 <a:latin typeface="Calibri"/>
               </a:rPr>
-              <a:t>· Email, wishlist, PWA</a:t>
+              <a:t>· Email, lista de deseos, PWA</a:t>
             </a:r>
           </a:p>
         </p:txBody>
@@ -5329,7 +5329,7 @@
                 </a:solidFill>
                 <a:latin typeface="Calibri"/>
               </a:rPr>
-              <a:t>What Was Achieved</a:t>
+              <a:t>Logros Obtenidos</a:t>
             </a:r>
           </a:p>
         </p:txBody>
@@ -5485,7 +5485,7 @@
                 </a:solidFill>
                 <a:latin typeface="Calibri"/>
               </a:rPr>
-              <a:t>features implemented</a:t>
+              <a:t>funcionalidades</a:t>
             </a:r>
           </a:p>
         </p:txBody>
@@ -5598,7 +5598,7 @@
                 </a:solidFill>
                 <a:latin typeface="Calibri"/>
               </a:rPr>
-              <a:t>API endpoints</a:t>
+              <a:t>endpoints API</a:t>
             </a:r>
           </a:p>
         </p:txBody>
@@ -5711,7 +5711,7 @@
                 </a:solidFill>
                 <a:latin typeface="Calibri"/>
               </a:rPr>
-              <a:t>external APIs</a:t>
+              <a:t>APIs externas</a:t>
             </a:r>
           </a:p>
         </p:txBody>
@@ -5824,7 +5824,7 @@
                 </a:solidFill>
                 <a:latin typeface="Calibri"/>
               </a:rPr>
-              <a:t>dev phases</a:t>
+              <a:t>fases de desarrollo</a:t>
             </a:r>
           </a:p>
         </p:txBody>
@@ -5859,7 +5859,7 @@
                 </a:solidFill>
                 <a:latin typeface="Calibri"/>
               </a:rPr>
-              <a:t>Delivered</a:t>
+              <a:t>Entregado</a:t>
             </a:r>
           </a:p>
         </p:txBody>
@@ -5898,7 +5898,7 @@
                 </a:solidFill>
                 <a:latin typeface="Calibri"/>
               </a:rPr>
-              <a:t>▸  Full e-commerce flow: browse → cart → crypto payment</a:t>
+              <a:t>▸  Flujo e-commerce completo: catalogo → carrito → pago crypto</a:t>
             </a:r>
           </a:p>
           <a:p>
@@ -5914,7 +5914,7 @@
                 </a:solidFill>
                 <a:latin typeface="Calibri"/>
               </a:rPr>
-              <a:t>▸  Ethereum payments via MetaMask on Sepolia testnet</a:t>
+              <a:t>▸  Pagos Ethereum via MetaMask en la red Sepolia</a:t>
             </a:r>
           </a:p>
           <a:p>
@@ -5930,7 +5930,7 @@
                 </a:solidFill>
                 <a:latin typeface="Calibri"/>
               </a:rPr>
-              <a:t>▸  Production-grade admin panel with Discogs import</a:t>
+              <a:t>▸  Panel de administracion con importacion desde Discogs</a:t>
             </a:r>
           </a:p>
           <a:p>
@@ -5946,7 +5946,7 @@
                 </a:solidFill>
                 <a:latin typeface="Calibri"/>
               </a:rPr>
-              <a:t>▸  JWT auth, order history, email receipts via Resend</a:t>
+              <a:t>▸  Auth JWT, historial de pedidos, recibos por email via Resend</a:t>
             </a:r>
           </a:p>
         </p:txBody>
@@ -5981,7 +5981,7 @@
                 </a:solidFill>
                 <a:latin typeface="Calibri"/>
               </a:rPr>
-              <a:t>Future improvements</a:t>
+              <a:t>Mejoras futuras</a:t>
             </a:r>
           </a:p>
         </p:txBody>
@@ -6020,7 +6020,7 @@
                 </a:solidFill>
                 <a:latin typeface="Calibri"/>
               </a:rPr>
-              <a:t>▸  Solidity escrow contract (buyer protection)</a:t>
+              <a:t>▸  Contrato Solidity de custodia (proteccion al comprador)</a:t>
             </a:r>
           </a:p>
           <a:p>
@@ -6036,7 +6036,7 @@
                 </a:solidFill>
                 <a:latin typeface="Calibri"/>
               </a:rPr>
-              <a:t>▸  Stock reservation during checkout</a:t>
+              <a:t>▸  Reserva de stock durante el checkout</a:t>
             </a:r>
           </a:p>
           <a:p>
@@ -6052,7 +6052,7 @@
                 </a:solidFill>
                 <a:latin typeface="Calibri"/>
               </a:rPr>
-              <a:t>▸  Image upload via Cloudinary</a:t>
+              <a:t>▸  Subida de imagenes via Cloudinary</a:t>
             </a:r>
           </a:p>
           <a:p>
@@ -6068,7 +6068,7 @@
                 </a:solidFill>
                 <a:latin typeface="Calibri"/>
               </a:rPr>
-              <a:t>▸  Automated test suite — Vitest + Jest + Supertest</a:t>
+              <a:t>▸  Suite de tests automatizados — Vitest + Jest + Supertest</a:t>
             </a:r>
           </a:p>
         </p:txBody>
@@ -6172,7 +6172,7 @@
                 </a:solidFill>
                 <a:latin typeface="Calibri"/>
               </a:rPr>
-              <a:t>Thank you.</a:t>
+              <a:t>Gracias.</a:t>
             </a:r>
           </a:p>
         </p:txBody>
@@ -6250,7 +6250,7 @@
                 </a:solidFill>
                 <a:latin typeface="Calibri"/>
               </a:rPr>
-              <a:t>Questions?</a:t>
+              <a:t>Preguntas?</a:t>
             </a:r>
           </a:p>
         </p:txBody>
@@ -6320,7 +6320,7 @@
                 </a:solidFill>
                 <a:latin typeface="Calibri"/>
               </a:rPr>
-              <a:t>Stepan Andreev  ·  Projecte Intermodular UD3  ·  June 2026</a:t>
+              <a:t>Stepan Andreev  ·  Projecte Intermodular UD3  ·  Junio 2026</a:t>
             </a:r>
           </a:p>
         </p:txBody>
@@ -6424,7 +6424,7 @@
                 </a:solidFill>
                 <a:latin typeface="Calibri"/>
               </a:rPr>
-              <a:t>The Project</a:t>
+              <a:t>El Proyecto</a:t>
             </a:r>
           </a:p>
         </p:txBody>
@@ -6502,7 +6502,7 @@
                 </a:solidFill>
                 <a:latin typeface="Calibri"/>
               </a:rPr>
-              <a:t>VinylEth is an online vinyl record store where customers pay with Ethereum through MetaMask — no traditional payment processor required.</a:t>
+              <a:t>VinylEth es una tienda online de vinilos donde los clientes pagan con Ethereum a traves de MetaMask, sin necesidad de procesadores de pago tradicionales.</a:t>
             </a:r>
           </a:p>
         </p:txBody>
@@ -6541,7 +6541,7 @@
                 </a:solidFill>
                 <a:latin typeface="Calibri"/>
               </a:rPr>
-              <a:t>▸  Vinyl revival: 45M records sold in 2023</a:t>
+              <a:t>▸  El vinilo ha vuelto: 45 millones de discos vendidos en 2023</a:t>
             </a:r>
           </a:p>
           <a:p>
@@ -6557,7 +6557,7 @@
                 </a:solidFill>
                 <a:latin typeface="Calibri"/>
               </a:rPr>
-              <a:t>▸  Target niche: vinyl fans + Web3 users</a:t>
+              <a:t>▸  Nicho objetivo: amantes del vinilo + usuarios Web3</a:t>
             </a:r>
           </a:p>
           <a:p>
@@ -6573,7 +6573,7 @@
                 </a:solidFill>
                 <a:latin typeface="Calibri"/>
               </a:rPr>
-              <a:t>▸  Privacy-first: no credit cards, no banks</a:t>
+              <a:t>▸  Privacidad: sin tarjetas de credito, sin bancos</a:t>
             </a:r>
           </a:p>
           <a:p>
@@ -6589,7 +6589,7 @@
                 </a:solidFill>
                 <a:latin typeface="Calibri"/>
               </a:rPr>
-              <a:t>▸  Full e-commerce flow: browse → cart → crypto payment</a:t>
+              <a:t>▸  Flujo e-commerce completo: catalogo → carrito → pago crypto</a:t>
             </a:r>
           </a:p>
           <a:p>
@@ -6605,7 +6605,7 @@
                 </a:solidFill>
                 <a:latin typeface="Calibri"/>
               </a:rPr>
-              <a:t>▸  Real on-chain transaction on Sepolia testnet</a:t>
+              <a:t>▸  Transaccion real en la red de pruebas Sepolia</a:t>
             </a:r>
           </a:p>
         </p:txBody>
@@ -6733,7 +6733,7 @@
                 </a:solidFill>
                 <a:latin typeface="Calibri"/>
               </a:rPr>
-              <a:t>Tech Stack</a:t>
+              <a:t>Tecnologias</a:t>
             </a:r>
           </a:p>
         </p:txBody>
@@ -6932,7 +6932,7 @@
                 </a:solidFill>
                 <a:latin typeface="Calibri"/>
               </a:rPr>
-              <a:t>Frontend SPA (Vite build tool)</a:t>
+              <a:t>SPA frontend (Vite)</a:t>
             </a:r>
           </a:p>
         </p:txBody>
@@ -7088,7 +7088,7 @@
                 </a:solidFill>
                 <a:latin typeface="Calibri"/>
               </a:rPr>
-              <a:t>REST API backend</a:t>
+              <a:t>API REST backend</a:t>
             </a:r>
           </a:p>
         </p:txBody>
@@ -7244,7 +7244,7 @@
                 </a:solidFill>
                 <a:latin typeface="Calibri"/>
               </a:rPr>
-              <a:t>NoSQL document database</a:t>
+              <a:t>Base de datos NoSQL</a:t>
             </a:r>
           </a:p>
         </p:txBody>
@@ -7400,7 +7400,7 @@
                 </a:solidFill>
                 <a:latin typeface="Calibri"/>
               </a:rPr>
-              <a:t>Stateless auth · password hashing</a:t>
+              <a:t>Autenticacion stateless · hash contrasenas</a:t>
             </a:r>
           </a:p>
         </p:txBody>
@@ -7556,7 +7556,7 @@
                 </a:solidFill>
                 <a:latin typeface="Calibri"/>
               </a:rPr>
-              <a:t>Ethereum payments — no extra lib</a:t>
+              <a:t>Pagos Ethereum — sin librerias extra</a:t>
             </a:r>
           </a:p>
         </p:txBody>
@@ -7712,7 +7712,7 @@
                 </a:solidFill>
                 <a:latin typeface="Calibri"/>
               </a:rPr>
-              <a:t>Album metadata · audio previews</a:t>
+              <a:t>Metadatos de albumes · previews de audio</a:t>
             </a:r>
           </a:p>
         </p:txBody>
@@ -7868,7 +7868,7 @@
                 </a:solidFill>
                 <a:latin typeface="Calibri"/>
               </a:rPr>
-              <a:t>Transactional email receipts</a:t>
+              <a:t>Recibos de pedido por correo</a:t>
             </a:r>
           </a:p>
         </p:txBody>
@@ -8024,7 +8024,7 @@
                 </a:solidFill>
                 <a:latin typeface="Calibri"/>
               </a:rPr>
-              <a:t>Add to Home Screen on mobile</a:t>
+              <a:t>Instalable en movil</a:t>
             </a:r>
           </a:p>
         </p:txBody>
@@ -8128,7 +8128,7 @@
                 </a:solidFill>
                 <a:latin typeface="Calibri"/>
               </a:rPr>
-              <a:t>Architecture</a:t>
+              <a:t>Arquitectura</a:t>
             </a:r>
           </a:p>
         </p:txBody>
@@ -8299,7 +8299,7 @@
                 </a:solidFill>
                 <a:latin typeface="Calibri"/>
               </a:rPr>
-              <a:t>Catalog &amp; Browsing</a:t>
+              <a:t>Catalogo y Navegacion</a:t>
             </a:r>
           </a:p>
         </p:txBody>
@@ -8405,7 +8405,7 @@
                 </a:solidFill>
                 <a:latin typeface="Calibri"/>
               </a:rPr>
-              <a:t>▸  Real-time search — 250ms debounce</a:t>
+              <a:t>▸  Busqueda en tiempo real — debounce 250ms</a:t>
             </a:r>
           </a:p>
           <a:p>
@@ -8421,7 +8421,7 @@
                 </a:solidFill>
                 <a:latin typeface="Calibri"/>
               </a:rPr>
-              <a:t>▸  Genre filter fetched from database</a:t>
+              <a:t>▸  Filtro por genero obtenido de la base de datos</a:t>
             </a:r>
           </a:p>
           <a:p>
@@ -8437,7 +8437,7 @@
                 </a:solidFill>
                 <a:latin typeface="Calibri"/>
               </a:rPr>
-              <a:t>▸  8 sort options (price, year, stock…)</a:t>
+              <a:t>▸  8 opciones de ordenacion (precio, año, stock...)</a:t>
             </a:r>
           </a:p>
           <a:p>
@@ -8453,7 +8453,7 @@
                 </a:solidFill>
                 <a:latin typeface="Calibri"/>
               </a:rPr>
-              <a:t>▸  Pagination via Load more</a:t>
+              <a:t>▸  Paginacion con boton Cargar mas</a:t>
             </a:r>
           </a:p>
           <a:p>
@@ -8469,7 +8469,7 @@
                 </a:solidFill>
                 <a:latin typeface="Calibri"/>
               </a:rPr>
-              <a:t>▸  Stock badges — Out of Stock / Last Copies</a:t>
+              <a:t>▸  Badges de stock — Sin stock / Ultimas copias</a:t>
             </a:r>
           </a:p>
           <a:p>
@@ -8501,7 +8501,7 @@
                 </a:solidFill>
                 <a:latin typeface="Calibri"/>
               </a:rPr>
-              <a:t>▸  Recently viewed shelf (localStorage)</a:t>
+              <a:t>▸  Vistos recientemente (localStorage)</a:t>
             </a:r>
           </a:p>
         </p:txBody>
@@ -8605,7 +8605,7 @@
                 </a:solidFill>
                 <a:latin typeface="Calibri"/>
               </a:rPr>
-              <a:t>Album Detail &amp; Audio Preview</a:t>
+              <a:t>Detalle de Album y Vista Previa</a:t>
             </a:r>
           </a:p>
         </p:txBody>
@@ -8711,7 +8711,7 @@
                 </a:solidFill>
                 <a:latin typeface="Calibri"/>
               </a:rPr>
-              <a:t>▸  Full metadata (label, country, format)</a:t>
+              <a:t>▸  Metadatos completos (sello, pais, formato)</a:t>
             </a:r>
           </a:p>
           <a:p>
@@ -8727,7 +8727,7 @@
                 </a:solidFill>
                 <a:latin typeface="Calibri"/>
               </a:rPr>
-              <a:t>▸  Tracklist with individual durations</a:t>
+              <a:t>▸  Tracklist con duraciones individuales</a:t>
             </a:r>
           </a:p>
           <a:p>
@@ -8743,7 +8743,7 @@
                 </a:solidFill>
                 <a:latin typeface="Calibri"/>
               </a:rPr>
-              <a:t>▸  Custom HTML5 audio player</a:t>
+              <a:t>▸  Reproductor HTML5 personalizado</a:t>
             </a:r>
           </a:p>
           <a:p>
@@ -8759,7 +8759,7 @@
                 </a:solidFill>
                 <a:latin typeface="Calibri"/>
               </a:rPr>
-              <a:t>▸    · Play/pause, seek bar, buffering</a:t>
+              <a:t>▸    · Play/pausa, barra de progreso, buffering</a:t>
             </a:r>
           </a:p>
           <a:p>
@@ -8775,7 +8775,7 @@
                 </a:solidFill>
                 <a:latin typeface="Calibri"/>
               </a:rPr>
-              <a:t>▸    · iTunes 30-second preview URL</a:t>
+              <a:t>▸    · Preview de 30 segundos via iTunes</a:t>
             </a:r>
           </a:p>
           <a:p>
@@ -8791,7 +8791,7 @@
                 </a:solidFill>
                 <a:latin typeface="Calibri"/>
               </a:rPr>
-              <a:t>▸  Similar albums (same genre, 4 items)</a:t>
+              <a:t>▸  Albumes similares (mismo genero, 4 items)</a:t>
             </a:r>
           </a:p>
           <a:p>
@@ -8807,7 +8807,7 @@
                 </a:solidFill>
                 <a:latin typeface="Calibri"/>
               </a:rPr>
-              <a:t>▸  Add to cart / wishlist toggle</a:t>
+              <a:t>▸  Anadir al carrito / toggle de lista de deseos</a:t>
             </a:r>
           </a:p>
         </p:txBody>
@@ -8911,7 +8911,7 @@
                 </a:solidFill>
                 <a:latin typeface="Calibri"/>
               </a:rPr>
-              <a:t>Checkout &amp; MetaMask Payment</a:t>
+              <a:t>Proceso de Pago con MetaMask</a:t>
             </a:r>
           </a:p>
         </p:txBody>
@@ -9013,7 +9013,7 @@
                 </a:solidFill>
                 <a:latin typeface="Calibri"/>
               </a:rPr>
-              <a:t>3-step flow:</a:t>
+              <a:t>Flujo en 3 pasos:</a:t>
             </a:r>
           </a:p>
         </p:txBody>
@@ -9052,7 +9052,7 @@
                 </a:solidFill>
                 <a:latin typeface="Calibri"/>
               </a:rPr>
-              <a:t>→  Cart  →  Shipping form  →  Payment</a:t>
+              <a:t>→  Carrito  →  Envio  →  Pago</a:t>
             </a:r>
           </a:p>
           <a:p>
@@ -9068,7 +9068,7 @@
                 </a:solidFill>
                 <a:latin typeface="Calibri"/>
               </a:rPr>
-              <a:t>→  Shipping address auto-filled from profile</a:t>
+              <a:t>→  Direccion de envio prellenada desde perfil</a:t>
             </a:r>
           </a:p>
           <a:p>
@@ -9084,7 +9084,7 @@
                 </a:solidFill>
                 <a:latin typeface="Calibri"/>
               </a:rPr>
-              <a:t>→  Chain switch to Sepolia (0xaa36a7)</a:t>
+              <a:t>→  Cambio de red a Sepolia (0xaa36a7)</a:t>
             </a:r>
           </a:p>
           <a:p>
@@ -9116,7 +9116,7 @@
                 </a:solidFill>
                 <a:latin typeface="Calibri"/>
               </a:rPr>
-              <a:t>→  ETH → Wei via BigInt (no float errors)</a:t>
+              <a:t>→  ETH → Wei con BigInt (sin errores de redondeo)</a:t>
             </a:r>
           </a:p>
           <a:p>
@@ -9132,7 +9132,7 @@
                 </a:solidFill>
                 <a:latin typeface="Calibri"/>
               </a:rPr>
-              <a:t>→  TX hash + Etherscan link on confirm</a:t>
+              <a:t>→  Hash TX + enlace a Etherscan al confirmar</a:t>
             </a:r>
           </a:p>
           <a:p>
@@ -9148,7 +9148,7 @@
                 </a:solidFill>
                 <a:latin typeface="Calibri"/>
               </a:rPr>
-              <a:t>→  Order saved to DB  +  email receipt sent</a:t>
+              <a:t>→  Pedido guardado en BD  +  recibo por email</a:t>
             </a:r>
           </a:p>
           <a:p>
@@ -9164,7 +9164,7 @@
                 </a:solidFill>
                 <a:latin typeface="Calibri"/>
               </a:rPr>
-              <a:t>→  Cart cleared automatically</a:t>
+              <a:t>→  Carrito vaciado automaticamente</a:t>
             </a:r>
           </a:p>
         </p:txBody>
@@ -9268,7 +9268,7 @@
                 </a:solidFill>
                 <a:latin typeface="Calibri"/>
               </a:rPr>
-              <a:t>Admin Panel</a:t>
+              <a:t>Panel de Administracion</a:t>
             </a:r>
           </a:p>
         </p:txBody>
@@ -9374,7 +9374,7 @@
                 </a:solidFill>
                 <a:latin typeface="Calibri"/>
               </a:rPr>
-              <a:t>▸  Dashboard: albums, orders, revenue, top sellers</a:t>
+              <a:t>▸  Dashboard: albumes, pedidos, ingresos, top ventas</a:t>
             </a:r>
           </a:p>
           <a:p>
@@ -9390,7 +9390,7 @@
                 </a:solidFill>
                 <a:latin typeface="Calibri"/>
               </a:rPr>
-              <a:t>▸  Album CRUD — full form</a:t>
+              <a:t>▸  CRUD de albumes — formulario completo</a:t>
             </a:r>
           </a:p>
           <a:p>
@@ -9406,7 +9406,7 @@
                 </a:solidFill>
                 <a:latin typeface="Calibri"/>
               </a:rPr>
-              <a:t>▸  Quick Discogs import (release ID → all fields)</a:t>
+              <a:t>▸  Importacion rapida de Discogs (ID → todos los campos)</a:t>
             </a:r>
           </a:p>
           <a:p>
@@ -9422,7 +9422,7 @@
                 </a:solidFill>
                 <a:latin typeface="Calibri"/>
               </a:rPr>
-              <a:t>▸  iTunes audio preview auto-fill</a:t>
+              <a:t>▸  Autorellenado de preview de audio desde iTunes</a:t>
             </a:r>
           </a:p>
           <a:p>
@@ -9438,7 +9438,7 @@
                 </a:solidFill>
                 <a:latin typeface="Calibri"/>
               </a:rPr>
-              <a:t>▸  Batch: discount %, featured flag, delete</a:t>
+              <a:t>▸  Operaciones en lote: descuento %, destacado, eliminar</a:t>
             </a:r>
           </a:p>
           <a:p>
@@ -9454,7 +9454,7 @@
                 </a:solidFill>
                 <a:latin typeface="Calibri"/>
               </a:rPr>
-              <a:t>▸  CSV export of album catalog</a:t>
+              <a:t>▸  Exportacion CSV del catalogo de albumes</a:t>
             </a:r>
           </a:p>
           <a:p>
@@ -9470,7 +9470,7 @@
                 </a:solidFill>
                 <a:latin typeface="Calibri"/>
               </a:rPr>
-              <a:t>▸  Order search by TX hash + date range</a:t>
+              <a:t>▸  Busqueda de pedidos por hash TX + rango de fechas</a:t>
             </a:r>
           </a:p>
           <a:p>
@@ -9486,7 +9486,7 @@
                 </a:solidFill>
                 <a:latin typeface="Calibri"/>
               </a:rPr>
-              <a:t>▸  Separate password auth (x-admin-token)</a:t>
+              <a:t>▸  Autenticacion separada por contrasena (x-admin-token)</a:t>
             </a:r>
           </a:p>
         </p:txBody>
@@ -9590,7 +9590,7 @@
                 </a:solidFill>
                 <a:latin typeface="Calibri"/>
               </a:rPr>
-              <a:t>Problems &amp; Solutions</a:t>
+              <a:t>Problemas y Soluciones</a:t>
             </a:r>
           </a:p>
         </p:txBody>
@@ -9754,7 +9754,7 @@
                 </a:solidFill>
                 <a:latin typeface="Calibri"/>
               </a:rPr>
-              <a:t>MongoDB SIGSEGV crash on development machine</a:t>
+              <a:t>MongoDB se bloqueaba con SIGSEGV en la maquina de desarrollo</a:t>
             </a:r>
           </a:p>
         </p:txBody>
@@ -9789,7 +9789,7 @@
                 </a:solidFill>
                 <a:latin typeface="Calibri"/>
               </a:rPr>
-              <a:t>⚠  Native mongodb-bin 8.2.7 crashed at startup on Arch Linux.</a:t>
+              <a:t>⚠  mongodb-bin 8.2.7 nativo crasheaba al arrancar en Arch Linux.</a:t>
             </a:r>
           </a:p>
         </p:txBody>
@@ -9824,7 +9824,7 @@
                 </a:solidFill>
                 <a:latin typeface="Calibri"/>
               </a:rPr>
-              <a:t>✓  Docker mongo:7 — stable DB, zero code changes needed.</a:t>
+              <a:t>✓  Docker mongo:7 — BD estable sin cambios en el codigo.</a:t>
             </a:r>
           </a:p>
         </p:txBody>
@@ -9945,7 +9945,7 @@
                 </a:solidFill>
                 <a:latin typeface="Calibri"/>
               </a:rPr>
-              <a:t>ETH → Wei floating-point precision loss</a:t>
+              <a:t>Perdida de precision al convertir ETH → Wei con coma flotante</a:t>
             </a:r>
           </a:p>
         </p:txBody>
@@ -9980,7 +9980,7 @@
                 </a:solidFill>
                 <a:latin typeface="Calibri"/>
               </a:rPr>
-              <a:t>⚠  amount * 1e18 produced rounding errors for values like 0.015 ETH.</a:t>
+              <a:t>⚠  amount * 1e18 producia errores de redondeo para valores como 0.015 ETH.</a:t>
             </a:r>
           </a:p>
         </p:txBody>
@@ -10015,7 +10015,7 @@
                 </a:solidFill>
                 <a:latin typeface="Calibri"/>
               </a:rPr>
-              <a:t>✓  BigInt arithmetic: split at decimal point, scale each part independently.</a:t>
+              <a:t>✓  Aritmetica BigInt: separar en parte entera y decimal, escalar cada una.</a:t>
             </a:r>
           </a:p>
         </p:txBody>
@@ -10136,7 +10136,7 @@
                 </a:solidFill>
                 <a:latin typeface="Calibri"/>
               </a:rPr>
-              <a:t>ESLint: CartContext exported provider + hook in same file</a:t>
+              <a:t>ESLint: CartContext exportaba provider y hook en el mismo archivo</a:t>
             </a:r>
           </a:p>
         </p:txBody>
@@ -10171,7 +10171,7 @@
                 </a:solidFill>
                 <a:latin typeface="Calibri"/>
               </a:rPr>
-              <a:t>⚠  React fast-refresh plugin rejected mixed exports.</a:t>
+              <a:t>⚠  El plugin React fast-refresh rechazaba las exportaciones mixtas.</a:t>
             </a:r>
           </a:p>
         </p:txBody>
@@ -10206,7 +10206,7 @@
                 </a:solidFill>
                 <a:latin typeface="Calibri"/>
               </a:rPr>
-              <a:t>✓  Split into useCart.js + cartContextValue.js — also improved SoC.</a:t>
+              <a:t>✓  Separado en useCart.js + cartContextValue.js — mejora tambien la SoC.</a:t>
             </a:r>
           </a:p>
         </p:txBody>

</xml_diff>